<commit_message>
Update 줄줄이 말해요 assets, add ZIP slides and round-trip variation
Co-Authored-By: Claude Opus 4.6 (1M context) <noreply@anthropic.com>
</commit_message>
<xml_diff>
--- a/public/downloads/games/chain-words/rules.pptx
+++ b/public/downloads/games/chain-words/rules.pptx
@@ -35,16 +35,12 @@
   <p:notesSz cx="6858000" cy="9144000"/>
   <p:embeddedFontLst>
     <p:embeddedFont>
-      <p:font typeface="Jua" charset="1" panose="00000000000000000000"/>
+      <p:font typeface="무궁화 고딕" charset="1" panose="02020603020101020101"/>
       <p:regular r:id="rId31"/>
     </p:embeddedFont>
     <p:embeddedFont>
-      <p:font typeface="TDTD갬성명조" charset="1" panose="02000503000000000000"/>
+      <p:font typeface="무궁화 고딕 Bold" charset="1" panose="02020603020101020101"/>
       <p:regular r:id="rId32"/>
-    </p:embeddedFont>
-    <p:embeddedFont>
-      <p:font typeface="TDTD가온" charset="1" panose="02000503000000000000"/>
-      <p:regular r:id="rId33"/>
     </p:embeddedFont>
   </p:embeddedFontLst>
   <p:defaultTextStyle>
@@ -3162,8 +3158,8 @@
         </p:nvSpPr>
         <p:spPr>
           <a:xfrm rot="0">
-            <a:off x="1028700" y="3892867"/>
-            <a:ext cx="15555091" cy="2200275"/>
+            <a:off x="1028700" y="4178617"/>
+            <a:ext cx="15555091" cy="1914525"/>
           </a:xfrm>
           <a:prstGeom prst="rect">
             <a:avLst/>
@@ -3185,10 +3181,10 @@
                 <a:solidFill>
                   <a:srgbClr val="FFFAEF"/>
                 </a:solidFill>
-                <a:latin typeface="Jua"/>
-                <a:ea typeface="Jua"/>
-                <a:cs typeface="Jua"/>
-                <a:sym typeface="Jua"/>
+                <a:latin typeface="무궁화 고딕"/>
+                <a:ea typeface="무궁화 고딕"/>
+                <a:cs typeface="무궁화 고딕"/>
+                <a:sym typeface="무궁화 고딕"/>
               </a:rPr>
               <a:t>줄줄이 말해요</a:t>
             </a:r>
@@ -3203,8 +3199,8 @@
         </p:nvSpPr>
         <p:spPr>
           <a:xfrm rot="0">
-            <a:off x="15264803" y="9812655"/>
-            <a:ext cx="2637975" cy="474345"/>
+            <a:off x="14663224" y="9822180"/>
+            <a:ext cx="3239554" cy="464820"/>
           </a:xfrm>
           <a:prstGeom prst="rect">
             <a:avLst/>
@@ -3229,10 +3225,10 @@
                 <a:solidFill>
                   <a:srgbClr val="FFFFFF"/>
                 </a:solidFill>
-                <a:latin typeface="TDTD갬성명조"/>
-                <a:ea typeface="TDTD갬성명조"/>
-                <a:cs typeface="TDTD갬성명조"/>
-                <a:sym typeface="TDTD갬성명조"/>
+                <a:latin typeface="무궁화 고딕"/>
+                <a:ea typeface="무궁화 고딕"/>
+                <a:cs typeface="무궁화 고딕"/>
+                <a:sym typeface="무궁화 고딕"/>
               </a:rPr>
               <a:t>ⓒ 2026. Sunday Play</a:t>
             </a:r>
@@ -3329,8 +3325,8 @@
         </p:nvSpPr>
         <p:spPr>
           <a:xfrm rot="0">
-            <a:off x="461635" y="3895725"/>
-            <a:ext cx="17364730" cy="2200275"/>
+            <a:off x="461635" y="4181475"/>
+            <a:ext cx="17364730" cy="1914525"/>
           </a:xfrm>
           <a:prstGeom prst="rect">
             <a:avLst/>
@@ -3352,10 +3348,10 @@
                 <a:solidFill>
                   <a:srgbClr val="000000"/>
                 </a:solidFill>
-                <a:latin typeface="Jua"/>
-                <a:ea typeface="Jua"/>
-                <a:cs typeface="Jua"/>
-                <a:sym typeface="Jua"/>
+                <a:latin typeface="무궁화 고딕"/>
+                <a:ea typeface="무궁화 고딕"/>
+                <a:cs typeface="무궁화 고딕"/>
+                <a:sym typeface="무궁화 고딕"/>
               </a:rPr>
               <a:t>초성이 'ㄱㅁ'인 단어</a:t>
             </a:r>
@@ -3452,8 +3448,8 @@
         </p:nvSpPr>
         <p:spPr>
           <a:xfrm rot="0">
-            <a:off x="461635" y="3895725"/>
-            <a:ext cx="17364730" cy="2200275"/>
+            <a:off x="461635" y="4181475"/>
+            <a:ext cx="17364730" cy="1914525"/>
           </a:xfrm>
           <a:prstGeom prst="rect">
             <a:avLst/>
@@ -3475,10 +3471,10 @@
                 <a:solidFill>
                   <a:srgbClr val="000000"/>
                 </a:solidFill>
-                <a:latin typeface="Jua"/>
-                <a:ea typeface="Jua"/>
-                <a:cs typeface="Jua"/>
-                <a:sym typeface="Jua"/>
+                <a:latin typeface="무궁화 고딕"/>
+                <a:ea typeface="무궁화 고딕"/>
+                <a:cs typeface="무궁화 고딕"/>
+                <a:sym typeface="무궁화 고딕"/>
               </a:rPr>
               <a:t>'면'자로 끝나는 말</a:t>
             </a:r>
@@ -3575,8 +3571,8 @@
         </p:nvSpPr>
         <p:spPr>
           <a:xfrm rot="0">
-            <a:off x="461635" y="3895725"/>
-            <a:ext cx="17364730" cy="2200275"/>
+            <a:off x="461635" y="4181475"/>
+            <a:ext cx="17364730" cy="1914525"/>
           </a:xfrm>
           <a:prstGeom prst="rect">
             <a:avLst/>
@@ -3598,10 +3594,10 @@
                 <a:solidFill>
                   <a:srgbClr val="000000"/>
                 </a:solidFill>
-                <a:latin typeface="Jua"/>
-                <a:ea typeface="Jua"/>
-                <a:cs typeface="Jua"/>
-                <a:sym typeface="Jua"/>
+                <a:latin typeface="무궁화 고딕"/>
+                <a:ea typeface="무궁화 고딕"/>
+                <a:cs typeface="무궁화 고딕"/>
+                <a:sym typeface="무궁화 고딕"/>
               </a:rPr>
               <a:t>학교에서 쓰는 물건</a:t>
             </a:r>
@@ -3698,8 +3694,8 @@
         </p:nvSpPr>
         <p:spPr>
           <a:xfrm rot="0">
-            <a:off x="461635" y="3895725"/>
-            <a:ext cx="17364730" cy="2200275"/>
+            <a:off x="461635" y="4181475"/>
+            <a:ext cx="17364730" cy="1914525"/>
           </a:xfrm>
           <a:prstGeom prst="rect">
             <a:avLst/>
@@ -3721,10 +3717,10 @@
                 <a:solidFill>
                   <a:srgbClr val="000000"/>
                 </a:solidFill>
-                <a:latin typeface="Jua"/>
-                <a:ea typeface="Jua"/>
-                <a:cs typeface="Jua"/>
-                <a:sym typeface="Jua"/>
+                <a:latin typeface="무궁화 고딕"/>
+                <a:ea typeface="무궁화 고딕"/>
+                <a:cs typeface="무궁화 고딕"/>
+                <a:sym typeface="무궁화 고딕"/>
               </a:rPr>
               <a:t>초성이 'ㅎㄱ'인 단어</a:t>
             </a:r>
@@ -3821,8 +3817,8 @@
         </p:nvSpPr>
         <p:spPr>
           <a:xfrm rot="0">
-            <a:off x="461635" y="3895725"/>
-            <a:ext cx="17364730" cy="2200275"/>
+            <a:off x="461635" y="4181475"/>
+            <a:ext cx="17364730" cy="1914525"/>
           </a:xfrm>
           <a:prstGeom prst="rect">
             <a:avLst/>
@@ -3844,10 +3840,10 @@
                 <a:solidFill>
                   <a:srgbClr val="000000"/>
                 </a:solidFill>
-                <a:latin typeface="Jua"/>
-                <a:ea typeface="Jua"/>
-                <a:cs typeface="Jua"/>
-                <a:sym typeface="Jua"/>
+                <a:latin typeface="무궁화 고딕"/>
+                <a:ea typeface="무궁화 고딕"/>
+                <a:cs typeface="무궁화 고딕"/>
+                <a:sym typeface="무궁화 고딕"/>
               </a:rPr>
               <a:t>'탕'자로 끝나는 말</a:t>
             </a:r>
@@ -3944,8 +3940,8 @@
         </p:nvSpPr>
         <p:spPr>
           <a:xfrm rot="0">
-            <a:off x="461635" y="3895725"/>
-            <a:ext cx="17364730" cy="2200275"/>
+            <a:off x="461635" y="4181475"/>
+            <a:ext cx="17364730" cy="1914525"/>
           </a:xfrm>
           <a:prstGeom prst="rect">
             <a:avLst/>
@@ -3967,10 +3963,10 @@
                 <a:solidFill>
                   <a:srgbClr val="000000"/>
                 </a:solidFill>
-                <a:latin typeface="Jua"/>
-                <a:ea typeface="Jua"/>
-                <a:cs typeface="Jua"/>
-                <a:sym typeface="Jua"/>
+                <a:latin typeface="무궁화 고딕"/>
+                <a:ea typeface="무궁화 고딕"/>
+                <a:cs typeface="무궁화 고딕"/>
+                <a:sym typeface="무궁화 고딕"/>
               </a:rPr>
               <a:t>놀이기구</a:t>
             </a:r>
@@ -4067,8 +4063,8 @@
         </p:nvSpPr>
         <p:spPr>
           <a:xfrm rot="0">
-            <a:off x="461635" y="3895725"/>
-            <a:ext cx="17364730" cy="2200275"/>
+            <a:off x="461635" y="4181475"/>
+            <a:ext cx="17364730" cy="1914525"/>
           </a:xfrm>
           <a:prstGeom prst="rect">
             <a:avLst/>
@@ -4090,10 +4086,10 @@
                 <a:solidFill>
                   <a:srgbClr val="000000"/>
                 </a:solidFill>
-                <a:latin typeface="Jua"/>
-                <a:ea typeface="Jua"/>
-                <a:cs typeface="Jua"/>
-                <a:sym typeface="Jua"/>
+                <a:latin typeface="무궁화 고딕"/>
+                <a:ea typeface="무궁화 고딕"/>
+                <a:cs typeface="무궁화 고딕"/>
+                <a:sym typeface="무궁화 고딕"/>
               </a:rPr>
               <a:t>초성이 'ㅅㅂ'인 단어</a:t>
             </a:r>
@@ -4190,8 +4186,8 @@
         </p:nvSpPr>
         <p:spPr>
           <a:xfrm rot="0">
-            <a:off x="461635" y="3895725"/>
-            <a:ext cx="17364730" cy="2200275"/>
+            <a:off x="461635" y="4181475"/>
+            <a:ext cx="17364730" cy="1914525"/>
           </a:xfrm>
           <a:prstGeom prst="rect">
             <a:avLst/>
@@ -4213,10 +4209,10 @@
                 <a:solidFill>
                   <a:srgbClr val="000000"/>
                 </a:solidFill>
-                <a:latin typeface="Jua"/>
-                <a:ea typeface="Jua"/>
-                <a:cs typeface="Jua"/>
-                <a:sym typeface="Jua"/>
+                <a:latin typeface="무궁화 고딕"/>
+                <a:ea typeface="무궁화 고딕"/>
+                <a:cs typeface="무궁화 고딕"/>
+                <a:sym typeface="무궁화 고딕"/>
               </a:rPr>
               <a:t>아이스크림 종류</a:t>
             </a:r>
@@ -4313,8 +4309,8 @@
         </p:nvSpPr>
         <p:spPr>
           <a:xfrm rot="0">
-            <a:off x="461635" y="3895725"/>
-            <a:ext cx="17364730" cy="2200275"/>
+            <a:off x="461635" y="4181475"/>
+            <a:ext cx="17364730" cy="1914525"/>
           </a:xfrm>
           <a:prstGeom prst="rect">
             <a:avLst/>
@@ -4336,10 +4332,10 @@
                 <a:solidFill>
                   <a:srgbClr val="000000"/>
                 </a:solidFill>
-                <a:latin typeface="Jua"/>
-                <a:ea typeface="Jua"/>
-                <a:cs typeface="Jua"/>
-                <a:sym typeface="Jua"/>
+                <a:latin typeface="무궁화 고딕"/>
+                <a:ea typeface="무궁화 고딕"/>
+                <a:cs typeface="무궁화 고딕"/>
+                <a:sym typeface="무궁화 고딕"/>
               </a:rPr>
               <a:t>초성이 'ㅅㄱ'인 단어</a:t>
             </a:r>
@@ -4436,8 +4432,8 @@
         </p:nvSpPr>
         <p:spPr>
           <a:xfrm rot="0">
-            <a:off x="461635" y="3895725"/>
-            <a:ext cx="17364730" cy="2200275"/>
+            <a:off x="461635" y="4181475"/>
+            <a:ext cx="17364730" cy="1914525"/>
           </a:xfrm>
           <a:prstGeom prst="rect">
             <a:avLst/>
@@ -4459,10 +4455,10 @@
                 <a:solidFill>
                   <a:srgbClr val="000000"/>
                 </a:solidFill>
-                <a:latin typeface="Jua"/>
-                <a:ea typeface="Jua"/>
-                <a:cs typeface="Jua"/>
-                <a:sym typeface="Jua"/>
+                <a:latin typeface="무궁화 고딕"/>
+                <a:ea typeface="무궁화 고딕"/>
+                <a:cs typeface="무궁화 고딕"/>
+                <a:sym typeface="무궁화 고딕"/>
               </a:rPr>
               <a:t>'사'자로 끝나는 말</a:t>
             </a:r>
@@ -4611,8 +4607,8 @@
         </p:nvSpPr>
         <p:spPr>
           <a:xfrm rot="0">
-            <a:off x="11392761" y="600705"/>
-            <a:ext cx="5362043" cy="1600200"/>
+            <a:off x="11392761" y="819780"/>
+            <a:ext cx="5362043" cy="1381125"/>
           </a:xfrm>
           <a:prstGeom prst="rect">
             <a:avLst/>
@@ -4634,10 +4630,10 @@
                 <a:solidFill>
                   <a:srgbClr val="FFFAEF"/>
                 </a:solidFill>
-                <a:latin typeface="Jua"/>
-                <a:ea typeface="Jua"/>
-                <a:cs typeface="Jua"/>
-                <a:sym typeface="Jua"/>
+                <a:latin typeface="무궁화 고딕"/>
+                <a:ea typeface="무궁화 고딕"/>
+                <a:cs typeface="무궁화 고딕"/>
+                <a:sym typeface="무궁화 고딕"/>
               </a:rPr>
               <a:t>규칙</a:t>
             </a:r>
@@ -4653,9 +4649,9 @@
         <p:grpSpPr>
           <a:xfrm rot="0">
             <a:off x="309172" y="535073"/>
-            <a:ext cx="6944841" cy="2573620"/>
+            <a:ext cx="6944841" cy="2370974"/>
             <a:chOff x="0" y="0"/>
-            <a:chExt cx="9259787" cy="3431493"/>
+            <a:chExt cx="9259787" cy="3161298"/>
           </a:xfrm>
         </p:grpSpPr>
         <p:sp>
@@ -4666,8 +4662,8 @@
           </p:nvSpPr>
           <p:spPr>
             <a:xfrm rot="0">
-              <a:off x="0" y="1380584"/>
-              <a:ext cx="9259787" cy="2050910"/>
+              <a:off x="0" y="1378853"/>
+              <a:ext cx="9259787" cy="1782445"/>
             </a:xfrm>
             <a:prstGeom prst="rect">
               <a:avLst/>
@@ -4681,18 +4677,18 @@
             <a:p>
               <a:pPr algn="l">
                 <a:lnSpc>
-                  <a:spcPts val="6273"/>
+                  <a:spcPts val="5459"/>
                 </a:lnSpc>
               </a:pPr>
               <a:r>
-                <a:rPr lang="en-US" sz="4480">
+                <a:rPr lang="en-US" sz="3900">
                   <a:solidFill>
                     <a:srgbClr val="FFFAEF"/>
                   </a:solidFill>
-                  <a:latin typeface="TDTD가온"/>
-                  <a:ea typeface="TDTD가온"/>
-                  <a:cs typeface="TDTD가온"/>
-                  <a:sym typeface="TDTD가온"/>
+                  <a:latin typeface="무궁화 고딕"/>
+                  <a:ea typeface="무궁화 고딕"/>
+                  <a:cs typeface="무궁화 고딕"/>
+                  <a:sym typeface="무궁화 고딕"/>
                 </a:rPr>
                 <a:t>진행자가 제시어를 말합니다.</a:t>
               </a:r>
@@ -4700,18 +4696,18 @@
             <a:p>
               <a:pPr algn="l">
                 <a:lnSpc>
-                  <a:spcPts val="6273"/>
+                  <a:spcPts val="5459"/>
                 </a:lnSpc>
               </a:pPr>
               <a:r>
-                <a:rPr lang="en-US" sz="4480">
+                <a:rPr lang="en-US" sz="3900">
                   <a:solidFill>
                     <a:srgbClr val="FFFAEF"/>
                   </a:solidFill>
-                  <a:latin typeface="TDTD가온"/>
-                  <a:ea typeface="TDTD가온"/>
-                  <a:cs typeface="TDTD가온"/>
-                  <a:sym typeface="TDTD가온"/>
+                  <a:latin typeface="무궁화 고딕"/>
+                  <a:ea typeface="무궁화 고딕"/>
+                  <a:cs typeface="무궁화 고딕"/>
+                  <a:sym typeface="무궁화 고딕"/>
                 </a:rPr>
                 <a:t>(예: '리'자로 끝나는 말, 분식 메뉴)</a:t>
               </a:r>
@@ -4726,8 +4722,8 @@
           </p:nvSpPr>
           <p:spPr>
             <a:xfrm rot="0">
-              <a:off x="0" y="-171450"/>
-              <a:ext cx="6217692" cy="1169217"/>
+              <a:off x="0" y="-66675"/>
+              <a:ext cx="6217692" cy="1062712"/>
             </a:xfrm>
             <a:prstGeom prst="rect">
               <a:avLst/>
@@ -4749,10 +4745,10 @@
                   <a:solidFill>
                     <a:srgbClr val="FFFAEF"/>
                   </a:solidFill>
-                  <a:latin typeface="Jua"/>
-                  <a:ea typeface="Jua"/>
-                  <a:cs typeface="Jua"/>
-                  <a:sym typeface="Jua"/>
+                  <a:latin typeface="무궁화 고딕 Bold"/>
+                  <a:ea typeface="무궁화 고딕 Bold"/>
+                  <a:cs typeface="무궁화 고딕 Bold"/>
+                  <a:sym typeface="무궁화 고딕 Bold"/>
                 </a:rPr>
                 <a:t>STEP 1.</a:t>
               </a:r>
@@ -4769,9 +4765,9 @@
         <p:grpSpPr>
           <a:xfrm rot="0">
             <a:off x="9639721" y="7511261"/>
-            <a:ext cx="8487123" cy="2574122"/>
+            <a:ext cx="8487123" cy="2402712"/>
             <a:chOff x="0" y="0"/>
-            <a:chExt cx="11316164" cy="3432162"/>
+            <a:chExt cx="11316164" cy="3203616"/>
           </a:xfrm>
         </p:grpSpPr>
         <p:sp>
@@ -4782,8 +4778,8 @@
           </p:nvSpPr>
           <p:spPr>
             <a:xfrm rot="0">
-              <a:off x="0" y="1377534"/>
-              <a:ext cx="11143161" cy="2054628"/>
+              <a:off x="0" y="1373758"/>
+              <a:ext cx="11143161" cy="1829858"/>
             </a:xfrm>
             <a:prstGeom prst="rect">
               <a:avLst/>
@@ -4797,18 +4793,18 @@
             <a:p>
               <a:pPr algn="l">
                 <a:lnSpc>
-                  <a:spcPts val="6284"/>
+                  <a:spcPts val="5600"/>
                 </a:lnSpc>
               </a:pPr>
               <a:r>
-                <a:rPr lang="en-US" sz="4489">
+                <a:rPr lang="en-US" sz="4000">
                   <a:solidFill>
                     <a:srgbClr val="FFFAEF"/>
                   </a:solidFill>
-                  <a:latin typeface="TDTD가온"/>
-                  <a:ea typeface="TDTD가온"/>
-                  <a:cs typeface="TDTD가온"/>
-                  <a:sym typeface="TDTD가온"/>
+                  <a:latin typeface="무궁화 고딕"/>
+                  <a:ea typeface="무궁화 고딕"/>
+                  <a:cs typeface="무궁화 고딕"/>
+                  <a:sym typeface="무궁화 고딕"/>
                 </a:rPr>
                 <a:t>팀원 전원 성공하면 점수!</a:t>
               </a:r>
@@ -4816,18 +4812,18 @@
             <a:p>
               <a:pPr algn="l">
                 <a:lnSpc>
-                  <a:spcPts val="6284"/>
+                  <a:spcPts val="5600"/>
                 </a:lnSpc>
               </a:pPr>
               <a:r>
-                <a:rPr lang="en-US" sz="4489">
+                <a:rPr lang="en-US" sz="4000">
                   <a:solidFill>
                     <a:srgbClr val="FFFAEF"/>
                   </a:solidFill>
-                  <a:latin typeface="TDTD가온"/>
-                  <a:ea typeface="TDTD가온"/>
-                  <a:cs typeface="TDTD가온"/>
-                  <a:sym typeface="TDTD가온"/>
+                  <a:latin typeface="무궁화 고딕"/>
+                  <a:ea typeface="무궁화 고딕"/>
+                  <a:cs typeface="무궁화 고딕"/>
+                  <a:sym typeface="무궁화 고딕"/>
                 </a:rPr>
                 <a:t>실패하면 다른 팀이 이어서 도전!</a:t>
               </a:r>
@@ -4842,8 +4838,8 @@
           </p:nvSpPr>
           <p:spPr>
             <a:xfrm rot="0">
-              <a:off x="0" y="-171450"/>
-              <a:ext cx="11316164" cy="1171105"/>
+              <a:off x="0" y="-57150"/>
+              <a:ext cx="11316164" cy="1053029"/>
             </a:xfrm>
             <a:prstGeom prst="rect">
               <a:avLst/>
@@ -4865,10 +4861,10 @@
                   <a:solidFill>
                     <a:srgbClr val="FFFAEF"/>
                   </a:solidFill>
-                  <a:latin typeface="Jua"/>
-                  <a:ea typeface="Jua"/>
-                  <a:cs typeface="Jua"/>
-                  <a:sym typeface="Jua"/>
+                  <a:latin typeface="무궁화 고딕 Bold"/>
+                  <a:ea typeface="무궁화 고딕 Bold"/>
+                  <a:cs typeface="무궁화 고딕 Bold"/>
+                  <a:sym typeface="무궁화 고딕 Bold"/>
                 </a:rPr>
                 <a:t>STEP 3.</a:t>
               </a:r>
@@ -4884,10 +4880,10 @@
         </p:nvGrpSpPr>
         <p:grpSpPr>
           <a:xfrm rot="0">
-            <a:off x="4316159" y="3878529"/>
-            <a:ext cx="10999209" cy="3364141"/>
+            <a:off x="4316159" y="4007523"/>
+            <a:ext cx="10999209" cy="2402261"/>
             <a:chOff x="0" y="0"/>
-            <a:chExt cx="14665612" cy="4485521"/>
+            <a:chExt cx="14665612" cy="3203015"/>
           </a:xfrm>
         </p:grpSpPr>
         <p:sp>
@@ -4898,8 +4894,8 @@
           </p:nvSpPr>
           <p:spPr>
             <a:xfrm rot="0">
-              <a:off x="0" y="1375218"/>
-              <a:ext cx="14665612" cy="3110303"/>
+              <a:off x="0" y="1382681"/>
+              <a:ext cx="14665612" cy="1820333"/>
             </a:xfrm>
             <a:prstGeom prst="rect">
               <a:avLst/>
@@ -4913,28 +4909,21 @@
             <a:p>
               <a:pPr algn="l">
                 <a:lnSpc>
-                  <a:spcPts val="6275"/>
+                  <a:spcPts val="5599"/>
                 </a:lnSpc>
               </a:pPr>
               <a:r>
-                <a:rPr lang="en-US" sz="4482">
+                <a:rPr lang="en-US" sz="3999">
                   <a:solidFill>
                     <a:srgbClr val="FFFAEF"/>
                   </a:solidFill>
-                  <a:latin typeface="TDTD가온"/>
-                  <a:ea typeface="TDTD가온"/>
-                  <a:cs typeface="TDTD가온"/>
-                  <a:sym typeface="TDTD가온"/>
+                  <a:latin typeface="무궁화 고딕"/>
+                  <a:ea typeface="무궁화 고딕"/>
+                  <a:cs typeface="무궁화 고딕"/>
+                  <a:sym typeface="무궁화 고딕"/>
                 </a:rPr>
                 <a:t>팀원들이 한 명씩 순서대로 3초 안에 단어를 말하세요! 중복은 안 됩니다!</a:t>
               </a:r>
-            </a:p>
-            <a:p>
-              <a:pPr algn="l">
-                <a:lnSpc>
-                  <a:spcPts val="6275"/>
-                </a:lnSpc>
-              </a:pPr>
             </a:p>
           </p:txBody>
         </p:sp>
@@ -4946,8 +4935,8 @@
           </p:nvSpPr>
           <p:spPr>
             <a:xfrm rot="0">
-              <a:off x="0" y="-171450"/>
-              <a:ext cx="4508525" cy="1169523"/>
+              <a:off x="0" y="-57150"/>
+              <a:ext cx="4508525" cy="1053161"/>
             </a:xfrm>
             <a:prstGeom prst="rect">
               <a:avLst/>
@@ -4969,10 +4958,10 @@
                   <a:solidFill>
                     <a:srgbClr val="FFFAEF"/>
                   </a:solidFill>
-                  <a:latin typeface="Jua"/>
-                  <a:ea typeface="Jua"/>
-                  <a:cs typeface="Jua"/>
-                  <a:sym typeface="Jua"/>
+                  <a:latin typeface="무궁화 고딕 Bold"/>
+                  <a:ea typeface="무궁화 고딕 Bold"/>
+                  <a:cs typeface="무궁화 고딕 Bold"/>
+                  <a:sym typeface="무궁화 고딕 Bold"/>
                 </a:rPr>
                 <a:t>STEP 2.</a:t>
               </a:r>
@@ -5070,8 +5059,8 @@
         </p:nvSpPr>
         <p:spPr>
           <a:xfrm rot="0">
-            <a:off x="461635" y="3895725"/>
-            <a:ext cx="17364730" cy="2200275"/>
+            <a:off x="461635" y="4181475"/>
+            <a:ext cx="17364730" cy="1914525"/>
           </a:xfrm>
           <a:prstGeom prst="rect">
             <a:avLst/>
@@ -5093,10 +5082,10 @@
                 <a:solidFill>
                   <a:srgbClr val="000000"/>
                 </a:solidFill>
-                <a:latin typeface="Jua"/>
-                <a:ea typeface="Jua"/>
-                <a:cs typeface="Jua"/>
-                <a:sym typeface="Jua"/>
+                <a:latin typeface="무궁화 고딕"/>
+                <a:ea typeface="무궁화 고딕"/>
+                <a:cs typeface="무궁화 고딕"/>
+                <a:sym typeface="무궁화 고딕"/>
               </a:rPr>
               <a:t>과일 이름</a:t>
             </a:r>
@@ -5193,8 +5182,8 @@
         </p:nvSpPr>
         <p:spPr>
           <a:xfrm rot="0">
-            <a:off x="461635" y="3895725"/>
-            <a:ext cx="17364730" cy="2200275"/>
+            <a:off x="461635" y="4181475"/>
+            <a:ext cx="17364730" cy="1914525"/>
           </a:xfrm>
           <a:prstGeom prst="rect">
             <a:avLst/>
@@ -5216,10 +5205,10 @@
                 <a:solidFill>
                   <a:srgbClr val="000000"/>
                 </a:solidFill>
-                <a:latin typeface="Jua"/>
-                <a:ea typeface="Jua"/>
-                <a:cs typeface="Jua"/>
-                <a:sym typeface="Jua"/>
+                <a:latin typeface="무궁화 고딕"/>
+                <a:ea typeface="무궁화 고딕"/>
+                <a:cs typeface="무궁화 고딕"/>
+                <a:sym typeface="무궁화 고딕"/>
               </a:rPr>
               <a:t>초성이 'ㄱㅈ'인 단어</a:t>
             </a:r>
@@ -5316,8 +5305,8 @@
         </p:nvSpPr>
         <p:spPr>
           <a:xfrm rot="0">
-            <a:off x="461635" y="3895725"/>
-            <a:ext cx="17364730" cy="2200275"/>
+            <a:off x="461635" y="4181475"/>
+            <a:ext cx="17364730" cy="1914525"/>
           </a:xfrm>
           <a:prstGeom prst="rect">
             <a:avLst/>
@@ -5339,10 +5328,10 @@
                 <a:solidFill>
                   <a:srgbClr val="000000"/>
                 </a:solidFill>
-                <a:latin typeface="Jua"/>
-                <a:ea typeface="Jua"/>
-                <a:cs typeface="Jua"/>
-                <a:sym typeface="Jua"/>
+                <a:latin typeface="무궁화 고딕"/>
+                <a:ea typeface="무궁화 고딕"/>
+                <a:cs typeface="무궁화 고딕"/>
+                <a:sym typeface="무궁화 고딕"/>
               </a:rPr>
               <a:t>'장'자로 끝나는 말</a:t>
             </a:r>
@@ -5439,8 +5428,8 @@
         </p:nvSpPr>
         <p:spPr>
           <a:xfrm rot="0">
-            <a:off x="461635" y="3895725"/>
-            <a:ext cx="17364730" cy="2200275"/>
+            <a:off x="461635" y="4181475"/>
+            <a:ext cx="17364730" cy="1914525"/>
           </a:xfrm>
           <a:prstGeom prst="rect">
             <a:avLst/>
@@ -5462,10 +5451,10 @@
                 <a:solidFill>
                   <a:srgbClr val="000000"/>
                 </a:solidFill>
-                <a:latin typeface="Jua"/>
-                <a:ea typeface="Jua"/>
-                <a:cs typeface="Jua"/>
-                <a:sym typeface="Jua"/>
+                <a:latin typeface="무궁화 고딕"/>
+                <a:ea typeface="무궁화 고딕"/>
+                <a:cs typeface="무궁화 고딕"/>
+                <a:sym typeface="무궁화 고딕"/>
               </a:rPr>
               <a:t>2글자 동물 이름</a:t>
             </a:r>
@@ -5562,8 +5551,8 @@
         </p:nvSpPr>
         <p:spPr>
           <a:xfrm rot="0">
-            <a:off x="461635" y="3895725"/>
-            <a:ext cx="17364730" cy="2200275"/>
+            <a:off x="461635" y="4181475"/>
+            <a:ext cx="17364730" cy="1914525"/>
           </a:xfrm>
           <a:prstGeom prst="rect">
             <a:avLst/>
@@ -5585,10 +5574,10 @@
                 <a:solidFill>
                   <a:srgbClr val="000000"/>
                 </a:solidFill>
-                <a:latin typeface="Jua"/>
-                <a:ea typeface="Jua"/>
-                <a:cs typeface="Jua"/>
-                <a:sym typeface="Jua"/>
+                <a:latin typeface="무궁화 고딕"/>
+                <a:ea typeface="무궁화 고딕"/>
+                <a:cs typeface="무궁화 고딕"/>
+                <a:sym typeface="무궁화 고딕"/>
               </a:rPr>
               <a:t>초성이 'ㅂㅅ'인 단어</a:t>
             </a:r>
@@ -5660,8 +5649,8 @@
         </p:nvSpPr>
         <p:spPr>
           <a:xfrm rot="0">
-            <a:off x="4421807" y="3895725"/>
-            <a:ext cx="9444385" cy="2200275"/>
+            <a:off x="4421807" y="4181475"/>
+            <a:ext cx="9444385" cy="1914525"/>
           </a:xfrm>
           <a:prstGeom prst="rect">
             <a:avLst/>
@@ -5683,10 +5672,10 @@
                 <a:solidFill>
                   <a:srgbClr val="000000"/>
                 </a:solidFill>
-                <a:latin typeface="Jua"/>
-                <a:ea typeface="Jua"/>
-                <a:cs typeface="Jua"/>
-                <a:sym typeface="Jua"/>
+                <a:latin typeface="무궁화 고딕"/>
+                <a:ea typeface="무궁화 고딕"/>
+                <a:cs typeface="무궁화 고딕"/>
+                <a:sym typeface="무궁화 고딕"/>
               </a:rPr>
               <a:t>감사합니다!</a:t>
             </a:r>
@@ -5783,8 +5772,8 @@
         </p:nvSpPr>
         <p:spPr>
           <a:xfrm rot="0">
-            <a:off x="3238925" y="4092795"/>
-            <a:ext cx="11810151" cy="2200275"/>
+            <a:off x="3238925" y="4378545"/>
+            <a:ext cx="11810151" cy="1914525"/>
           </a:xfrm>
           <a:prstGeom prst="rect">
             <a:avLst/>
@@ -5806,10 +5795,10 @@
                 <a:solidFill>
                   <a:srgbClr val="000000"/>
                 </a:solidFill>
-                <a:latin typeface="Jua"/>
-                <a:ea typeface="Jua"/>
-                <a:cs typeface="Jua"/>
-                <a:sym typeface="Jua"/>
+                <a:latin typeface="무궁화 고딕"/>
+                <a:ea typeface="무궁화 고딕"/>
+                <a:cs typeface="무궁화 고딕"/>
+                <a:sym typeface="무궁화 고딕"/>
               </a:rPr>
               <a:t>팀을 나눠주세요!</a:t>
             </a:r>
@@ -5956,8 +5945,8 @@
         </p:nvSpPr>
         <p:spPr>
           <a:xfrm rot="0">
-            <a:off x="1028700" y="3892867"/>
-            <a:ext cx="15555091" cy="2200275"/>
+            <a:off x="1028700" y="4178617"/>
+            <a:ext cx="15555091" cy="1914525"/>
           </a:xfrm>
           <a:prstGeom prst="rect">
             <a:avLst/>
@@ -5979,10 +5968,10 @@
                 <a:solidFill>
                   <a:srgbClr val="FFFAEF"/>
                 </a:solidFill>
-                <a:latin typeface="Jua"/>
-                <a:ea typeface="Jua"/>
-                <a:cs typeface="Jua"/>
-                <a:sym typeface="Jua"/>
+                <a:latin typeface="무궁화 고딕"/>
+                <a:ea typeface="무궁화 고딕"/>
+                <a:cs typeface="무궁화 고딕"/>
+                <a:sym typeface="무궁화 고딕"/>
               </a:rPr>
               <a:t>줄줄이 말해요</a:t>
             </a:r>
@@ -5997,8 +5986,8 @@
         </p:nvSpPr>
         <p:spPr>
           <a:xfrm rot="0">
-            <a:off x="15264803" y="9812655"/>
-            <a:ext cx="2637975" cy="474345"/>
+            <a:off x="14663224" y="9822180"/>
+            <a:ext cx="3239554" cy="464820"/>
           </a:xfrm>
           <a:prstGeom prst="rect">
             <a:avLst/>
@@ -6023,10 +6012,10 @@
                 <a:solidFill>
                   <a:srgbClr val="FFFFFF"/>
                 </a:solidFill>
-                <a:latin typeface="TDTD갬성명조"/>
-                <a:ea typeface="TDTD갬성명조"/>
-                <a:cs typeface="TDTD갬성명조"/>
-                <a:sym typeface="TDTD갬성명조"/>
+                <a:latin typeface="무궁화 고딕"/>
+                <a:ea typeface="무궁화 고딕"/>
+                <a:cs typeface="무궁화 고딕"/>
+                <a:sym typeface="무궁화 고딕"/>
               </a:rPr>
               <a:t>ⓒ 2026. Sunday Play</a:t>
             </a:r>
@@ -6123,8 +6112,8 @@
         </p:nvSpPr>
         <p:spPr>
           <a:xfrm rot="0">
-            <a:off x="461635" y="3895725"/>
-            <a:ext cx="17364730" cy="2200275"/>
+            <a:off x="461635" y="4181475"/>
+            <a:ext cx="17364730" cy="1914525"/>
           </a:xfrm>
           <a:prstGeom prst="rect">
             <a:avLst/>
@@ -6146,10 +6135,10 @@
                 <a:solidFill>
                   <a:srgbClr val="000000"/>
                 </a:solidFill>
-                <a:latin typeface="Jua"/>
-                <a:ea typeface="Jua"/>
-                <a:cs typeface="Jua"/>
-                <a:sym typeface="Jua"/>
+                <a:latin typeface="무궁화 고딕"/>
+                <a:ea typeface="무궁화 고딕"/>
+                <a:cs typeface="무궁화 고딕"/>
+                <a:sym typeface="무궁화 고딕"/>
               </a:rPr>
               <a:t>'빵'자로 끝나는 말</a:t>
             </a:r>
@@ -6246,8 +6235,8 @@
         </p:nvSpPr>
         <p:spPr>
           <a:xfrm rot="0">
-            <a:off x="461635" y="3895725"/>
-            <a:ext cx="17364730" cy="2200275"/>
+            <a:off x="461635" y="4181475"/>
+            <a:ext cx="17364730" cy="1914525"/>
           </a:xfrm>
           <a:prstGeom prst="rect">
             <a:avLst/>
@@ -6269,10 +6258,10 @@
                 <a:solidFill>
                   <a:srgbClr val="000000"/>
                 </a:solidFill>
-                <a:latin typeface="Jua"/>
-                <a:ea typeface="Jua"/>
-                <a:cs typeface="Jua"/>
-                <a:sym typeface="Jua"/>
+                <a:latin typeface="무궁화 고딕"/>
+                <a:ea typeface="무궁화 고딕"/>
+                <a:cs typeface="무궁화 고딕"/>
+                <a:sym typeface="무궁화 고딕"/>
               </a:rPr>
               <a:t>분식 메뉴</a:t>
             </a:r>
@@ -6369,8 +6358,8 @@
         </p:nvSpPr>
         <p:spPr>
           <a:xfrm rot="0">
-            <a:off x="461635" y="3895725"/>
-            <a:ext cx="17364730" cy="2200275"/>
+            <a:off x="461635" y="4181475"/>
+            <a:ext cx="17364730" cy="1914525"/>
           </a:xfrm>
           <a:prstGeom prst="rect">
             <a:avLst/>
@@ -6392,10 +6381,10 @@
                 <a:solidFill>
                   <a:srgbClr val="000000"/>
                 </a:solidFill>
-                <a:latin typeface="Jua"/>
-                <a:ea typeface="Jua"/>
-                <a:cs typeface="Jua"/>
-                <a:sym typeface="Jua"/>
+                <a:latin typeface="무궁화 고딕"/>
+                <a:ea typeface="무궁화 고딕"/>
+                <a:cs typeface="무궁화 고딕"/>
+                <a:sym typeface="무궁화 고딕"/>
               </a:rPr>
               <a:t>1글자 신체 부위</a:t>
             </a:r>
@@ -6492,8 +6481,8 @@
         </p:nvSpPr>
         <p:spPr>
           <a:xfrm rot="0">
-            <a:off x="461635" y="3895725"/>
-            <a:ext cx="17364730" cy="2200275"/>
+            <a:off x="461635" y="4181475"/>
+            <a:ext cx="17364730" cy="1914525"/>
           </a:xfrm>
           <a:prstGeom prst="rect">
             <a:avLst/>
@@ -6515,10 +6504,10 @@
                 <a:solidFill>
                   <a:srgbClr val="000000"/>
                 </a:solidFill>
-                <a:latin typeface="Jua"/>
-                <a:ea typeface="Jua"/>
-                <a:cs typeface="Jua"/>
-                <a:sym typeface="Jua"/>
+                <a:latin typeface="무궁화 고딕"/>
+                <a:ea typeface="무궁화 고딕"/>
+                <a:cs typeface="무궁화 고딕"/>
+                <a:sym typeface="무궁화 고딕"/>
               </a:rPr>
               <a:t>'기'자로 끝나는 말</a:t>
             </a:r>
@@ -6615,8 +6604,8 @@
         </p:nvSpPr>
         <p:spPr>
           <a:xfrm rot="0">
-            <a:off x="461635" y="3895725"/>
-            <a:ext cx="17364730" cy="2200275"/>
+            <a:off x="461635" y="4181475"/>
+            <a:ext cx="17364730" cy="1914525"/>
           </a:xfrm>
           <a:prstGeom prst="rect">
             <a:avLst/>
@@ -6638,10 +6627,10 @@
                 <a:solidFill>
                   <a:srgbClr val="000000"/>
                 </a:solidFill>
-                <a:latin typeface="Jua"/>
-                <a:ea typeface="Jua"/>
-                <a:cs typeface="Jua"/>
-                <a:sym typeface="Jua"/>
+                <a:latin typeface="무궁화 고딕"/>
+                <a:ea typeface="무궁화 고딕"/>
+                <a:cs typeface="무궁화 고딕"/>
+                <a:sym typeface="무궁화 고딕"/>
               </a:rPr>
               <a:t>라면 이름</a:t>
             </a:r>

</xml_diff>